<commit_message>
Corregir orientacion: el norte real esta 7 grados al este
Todo el proyecto asumia el norte 7 grados al oeste. Se recalcularon zonas de sombra, corrimientos y techo con calculos/sombra_orientacion.py y se actualizaron la presentacion, los dos docx, el sol, la flecha N y el contorno de la zona en los .blend, y los renders de ideas iniciales.
</commit_message>
<xml_diff>
--- a/Sombra_patio_17_octubre.pptx
+++ b/Sombra_patio_17_octubre.pptx
@@ -3669,7 +3669,7 @@
                 </a:solidFill>
                 <a:latin typeface="Calibri"/>
               </a:rPr>
-              <a:t>el norte está 7° a la izquierda de la pared larga</a:t>
+              <a:t>el norte está 7° a la derecha (hacia el este) de la pared larga</a:t>
             </a:r>
           </a:p>
         </p:txBody>
@@ -4113,7 +4113,7 @@
                 </a:solidFill>
                 <a:latin typeface="Calibri"/>
               </a:rPr>
-              <a:t>46%</a:t>
+              <a:t>45%</a:t>
             </a:r>
           </a:p>
         </p:txBody>
@@ -4317,7 +4317,7 @@
                 </a:solidFill>
                 <a:latin typeface="Calibri"/>
               </a:rPr>
-              <a:t>44%</a:t>
+              <a:t>46%</a:t>
             </a:r>
           </a:p>
         </p:txBody>
@@ -4419,7 +4419,7 @@
                 </a:solidFill>
                 <a:latin typeface="Calibri"/>
               </a:rPr>
-              <a:t>51%</a:t>
+              <a:t>56%</a:t>
             </a:r>
           </a:p>
         </p:txBody>
@@ -4695,7 +4695,7 @@
                 </a:solidFill>
                 <a:latin typeface="Calibri"/>
               </a:rPr>
-              <a:t>309 m²  ·  31% del patio</a:t>
+              <a:t>344 m²  ·  34% del patio</a:t>
             </a:r>
           </a:p>
         </p:txBody>
@@ -4887,7 +4887,7 @@
                 </a:solidFill>
                 <a:latin typeface="Calibri"/>
               </a:rPr>
-              <a:t>342 m²  ·  34% del patio</a:t>
+              <a:t>315 m²  ·  32% del patio</a:t>
             </a:r>
           </a:p>
         </p:txBody>
@@ -5079,7 +5079,7 @@
                 </a:solidFill>
                 <a:latin typeface="Calibri"/>
               </a:rPr>
-              <a:t>348 m²  ·  35% del patio</a:t>
+              <a:t>340 m²  ·  34% del patio</a:t>
             </a:r>
           </a:p>
         </p:txBody>
@@ -5309,7 +5309,7 @@
                 </a:solidFill>
                 <a:latin typeface="Calibri"/>
               </a:rPr>
-              <a:t>Sin sombra: 23,5 × 14,8 m (348 m²). Empieza a 12,9 m de la pared oeste y a 4,5 m de la este, pegado al borde abierto.</a:t>
+              <a:t>Sin sombra: 23,4 × 14,5 m (340 m²). Empieza a 10,8 m de la pared oeste y a 6,7 m de la este, pegado al borde abierto.</a:t>
             </a:r>
           </a:p>
         </p:txBody>
@@ -5421,7 +5421,7 @@
                 </a:solidFill>
                 <a:latin typeface="Calibri"/>
               </a:rPr>
-              <a:t>Para cubrir también la sombra intermitente: 40,9 × 17,4 m (712 m²), todo el frente.</a:t>
+              <a:t>Para cubrir también la sombra intermitente: 40,9 × 16,2 m (661 m²), todo el frente.</a:t>
             </a:r>
           </a:p>
         </p:txBody>
@@ -5533,7 +5533,7 @@
                 </a:solidFill>
                 <a:latin typeface="Calibri"/>
               </a:rPr>
-              <a:t>Banda de 7,0 m junto a la pared norte: ya tiene sombra todo el evento.</a:t>
+              <a:t>Banda de 8,3 m junto a la pared norte: ya tiene sombra todo el evento.</a:t>
             </a:r>
           </a:p>
         </p:txBody>

</xml_diff>